<commit_message>
Tachu Honesty deck: one topic only
The school agreed to drop SDG 14 from this lesson. The ocean section
is replaced by a class promise and a bonus question about white lies.

Co-Authored-By: Claude Opus 5.5 <noreply@anthropic.com>
</commit_message>
<xml_diff>
--- a/slides/tachu-elem-honesty/tachu-elem-honesty.pptx
+++ b/slides/tachu-elem-honesty/tachu-elem-honesty.pptx
@@ -35,8 +35,6 @@
     <p:sldId id="283" r:id="rId34"/>
     <p:sldId id="284" r:id="rId35"/>
     <p:sldId id="285" r:id="rId36"/>
-    <p:sldId id="286" r:id="rId37"/>
-    <p:sldId id="287" r:id="rId38"/>
   </p:sldIdLst>
   <p:sldSz cx="12191695" cy="6858000" type="screen4x3"/>
   <p:notesSz cx="6858000" cy="9144000"/>
@@ -3879,7 +3877,7 @@
       <p:grpSpPr/>
       <p:pic>
         <p:nvPicPr>
-          <p:cNvPr id="2" name="Picture 1" descr="025.jpg"/>
+          <p:cNvPr id="2" name="Picture 1" descr="025.png"/>
           <p:cNvPicPr>
             <a:picLocks noChangeAspect="1"/>
           </p:cNvPicPr>
@@ -4005,9 +4003,7 @@
       <p:grpSpPr/>
       <p:pic>
         <p:nvPicPr>
-          <p:cNvPr id="2" name="Picture 1" descr="028.png">
-            <a:hlinkClick r:id="rId3"/>
-          </p:cNvPr>
+          <p:cNvPr id="2" name="Picture 1" descr="028.png"/>
           <p:cNvPicPr>
             <a:picLocks noChangeAspect="1"/>
           </p:cNvPicPr>
@@ -4092,90 +4088,6 @@
       <p:pic>
         <p:nvPicPr>
           <p:cNvPr id="2" name="Picture 1" descr="029.png"/>
-          <p:cNvPicPr>
-            <a:picLocks noChangeAspect="1"/>
-          </p:cNvPicPr>
-          <p:nvPr/>
-        </p:nvPicPr>
-        <p:blipFill>
-          <a:blip r:embed="rId2"/>
-          <a:stretch>
-            <a:fillRect/>
-          </a:stretch>
-        </p:blipFill>
-        <p:spPr>
-          <a:xfrm>
-            <a:off x="0" y="0"/>
-            <a:ext cx="12191695" cy="6858000"/>
-          </a:xfrm>
-          <a:prstGeom prst="rect">
-            <a:avLst/>
-          </a:prstGeom>
-        </p:spPr>
-      </p:pic>
-    </p:spTree>
-  </p:cSld>
-  <p:clrMapOvr>
-    <a:masterClrMapping/>
-  </p:clrMapOvr>
-</p:sld>
-</file>
-
-<file path=ppt/slides/slide31.xml><?xml version="1.0" encoding="utf-8"?>
-<p:sld xmlns:a="http://schemas.openxmlformats.org/drawingml/2006/main" xmlns:p="http://schemas.openxmlformats.org/presentationml/2006/main" xmlns:r="http://schemas.openxmlformats.org/officeDocument/2006/relationships">
-  <p:cSld>
-    <p:spTree>
-      <p:nvGrpSpPr>
-        <p:cNvPr id="1" name=""/>
-        <p:cNvGrpSpPr/>
-        <p:nvPr/>
-      </p:nvGrpSpPr>
-      <p:grpSpPr/>
-      <p:pic>
-        <p:nvPicPr>
-          <p:cNvPr id="2" name="Picture 1" descr="030.png"/>
-          <p:cNvPicPr>
-            <a:picLocks noChangeAspect="1"/>
-          </p:cNvPicPr>
-          <p:nvPr/>
-        </p:nvPicPr>
-        <p:blipFill>
-          <a:blip r:embed="rId2"/>
-          <a:stretch>
-            <a:fillRect/>
-          </a:stretch>
-        </p:blipFill>
-        <p:spPr>
-          <a:xfrm>
-            <a:off x="0" y="0"/>
-            <a:ext cx="12191695" cy="6858000"/>
-          </a:xfrm>
-          <a:prstGeom prst="rect">
-            <a:avLst/>
-          </a:prstGeom>
-        </p:spPr>
-      </p:pic>
-    </p:spTree>
-  </p:cSld>
-  <p:clrMapOvr>
-    <a:masterClrMapping/>
-  </p:clrMapOvr>
-</p:sld>
-</file>
-
-<file path=ppt/slides/slide32.xml><?xml version="1.0" encoding="utf-8"?>
-<p:sld xmlns:a="http://schemas.openxmlformats.org/drawingml/2006/main" xmlns:p="http://schemas.openxmlformats.org/presentationml/2006/main" xmlns:r="http://schemas.openxmlformats.org/officeDocument/2006/relationships">
-  <p:cSld>
-    <p:spTree>
-      <p:nvGrpSpPr>
-        <p:cNvPr id="1" name=""/>
-        <p:cNvGrpSpPr/>
-        <p:nvPr/>
-      </p:nvGrpSpPr>
-      <p:grpSpPr/>
-      <p:pic>
-        <p:nvPicPr>
-          <p:cNvPr id="2" name="Picture 1" descr="031.png"/>
           <p:cNvPicPr>
             <a:picLocks noChangeAspect="1"/>
           </p:cNvPicPr>

</xml_diff>